<commit_message>
Add ShipShape security audit category
</commit_message>
<xml_diff>
--- a/shipshape/ShipShape_Demo_Deck.pptx
+++ b/shipshape/ShipShape_Demo_Deck.pptx
@@ -36,6 +36,7 @@
     <p:sldId id="284" r:id="rId39"/>
     <p:sldId id="285" r:id="rId40"/>
     <p:sldId id="286" r:id="rId41"/>
+    <p:sldId id="287" r:id="rId42"/>
   </p:sldIdLst>
   <p:sldSz cx="14630400" cy="8229600" type="screen4x3"/>
   <p:notesSz cx="6858000" cy="9144000"/>
@@ -4150,6 +4151,682 @@
           </a:prstGeom>
         </p:spPr>
       </p:pic>
+    </p:spTree>
+  </p:cSld>
+  <p:clrMapOvr>
+    <a:masterClrMapping/>
+  </p:clrMapOvr>
+</p:sld>
+</file>
+
+<file path=ppt/slides/slide32.xml><?xml version="1.0" encoding="utf-8"?>
+<p:sld xmlns:a="http://schemas.openxmlformats.org/drawingml/2006/main" xmlns:p="http://schemas.openxmlformats.org/presentationml/2006/main" xmlns:r="http://schemas.openxmlformats.org/officeDocument/2006/relationships">
+  <p:cSld>
+    <p:bg>
+      <p:bgPr>
+        <a:solidFill>
+          <a:srgbClr val="0D1220"/>
+        </a:solidFill>
+        <a:effectLst/>
+      </p:bgPr>
+    </p:bg>
+    <p:spTree>
+      <p:nvGrpSpPr>
+        <p:cNvPr id="1" name=""/>
+        <p:cNvGrpSpPr/>
+        <p:nvPr/>
+      </p:nvGrpSpPr>
+      <p:grpSpPr/>
+      <p:sp>
+        <p:nvSpPr>
+          <p:cNvPr id="2" name="Rectangle 1"/>
+          <p:cNvSpPr/>
+          <p:nvPr/>
+        </p:nvSpPr>
+        <p:spPr>
+          <a:xfrm>
+            <a:off x="0" y="0"/>
+            <a:ext cx="14630400" cy="109728"/>
+          </a:xfrm>
+          <a:prstGeom prst="rect">
+            <a:avLst/>
+          </a:prstGeom>
+          <a:solidFill>
+            <a:srgbClr val="2A9D8F"/>
+          </a:solidFill>
+          <a:ln>
+            <a:noFill/>
+          </a:ln>
+        </p:spPr>
+        <p:style>
+          <a:lnRef idx="1">
+            <a:schemeClr val="accent1"/>
+          </a:lnRef>
+          <a:fillRef idx="3">
+            <a:schemeClr val="accent1"/>
+          </a:fillRef>
+          <a:effectRef idx="2">
+            <a:schemeClr val="accent1"/>
+          </a:effectRef>
+          <a:fontRef idx="minor">
+            <a:schemeClr val="lt1"/>
+          </a:fontRef>
+        </p:style>
+        <p:txBody>
+          <a:bodyPr rtlCol="0" anchor="ctr"/>
+          <a:lstStyle/>
+          <a:p>
+            <a:pPr algn="ctr"/>
+          </a:p>
+        </p:txBody>
+      </p:sp>
+      <p:sp>
+        <p:nvSpPr>
+          <p:cNvPr id="3" name="TextBox 2"/>
+          <p:cNvSpPr txBox="1"/>
+          <p:nvPr/>
+        </p:nvSpPr>
+        <p:spPr>
+          <a:xfrm>
+            <a:off x="502920" y="384048"/>
+            <a:ext cx="11155680" cy="502920"/>
+          </a:xfrm>
+          <a:prstGeom prst="rect">
+            <a:avLst/>
+          </a:prstGeom>
+          <a:noFill/>
+        </p:spPr>
+        <p:txBody>
+          <a:bodyPr wrap="none">
+            <a:spAutoFit/>
+          </a:bodyPr>
+          <a:lstStyle/>
+          <a:p>
+            <a:pPr>
+              <a:defRPr sz="3000" b="1">
+                <a:solidFill>
+                  <a:srgbClr val="F8FAFC"/>
+                </a:solidFill>
+              </a:defRPr>
+            </a:pPr>
+            <a:r>
+              <a:t>Category 8: Security Audit</a:t>
+            </a:r>
+          </a:p>
+        </p:txBody>
+      </p:sp>
+      <p:sp>
+        <p:nvSpPr>
+          <p:cNvPr id="4" name="TextBox 3"/>
+          <p:cNvSpPr txBox="1"/>
+          <p:nvPr/>
+        </p:nvSpPr>
+        <p:spPr>
+          <a:xfrm>
+            <a:off x="530352" y="896112"/>
+            <a:ext cx="10972800" cy="320040"/>
+          </a:xfrm>
+          <a:prstGeom prst="rect">
+            <a:avLst/>
+          </a:prstGeom>
+          <a:noFill/>
+        </p:spPr>
+        <p:txBody>
+          <a:bodyPr wrap="none">
+            <a:spAutoFit/>
+          </a:bodyPr>
+          <a:lstStyle/>
+          <a:p>
+            <a:pPr>
+              <a:defRPr sz="1300">
+                <a:solidFill>
+                  <a:srgbClr val="BAC2D0"/>
+                </a:solidFill>
+              </a:defRPr>
+            </a:pPr>
+            <a:r>
+              <a:t>Runnable active probe, before/after evidence, and two verified fixes</a:t>
+            </a:r>
+          </a:p>
+        </p:txBody>
+      </p:sp>
+      <p:sp>
+        <p:nvSpPr>
+          <p:cNvPr id="5" name="Rounded Rectangle 4"/>
+          <p:cNvSpPr/>
+          <p:nvPr/>
+        </p:nvSpPr>
+        <p:spPr>
+          <a:xfrm>
+            <a:off x="594360" y="1417320"/>
+            <a:ext cx="2514600" cy="1051560"/>
+          </a:xfrm>
+          <a:prstGeom prst="roundRect">
+            <a:avLst/>
+          </a:prstGeom>
+          <a:solidFill>
+            <a:srgbClr val="161E30"/>
+          </a:solidFill>
+          <a:ln w="12700">
+            <a:solidFill>
+              <a:srgbClr val="2F3A52"/>
+            </a:solidFill>
+          </a:ln>
+        </p:spPr>
+        <p:style>
+          <a:lnRef idx="1">
+            <a:schemeClr val="accent1"/>
+          </a:lnRef>
+          <a:fillRef idx="3">
+            <a:schemeClr val="accent1"/>
+          </a:fillRef>
+          <a:effectRef idx="2">
+            <a:schemeClr val="accent1"/>
+          </a:effectRef>
+          <a:fontRef idx="minor">
+            <a:schemeClr val="lt1"/>
+          </a:fontRef>
+        </p:style>
+        <p:txBody>
+          <a:bodyPr rtlCol="0" anchor="ctr" lIns="146304" rIns="146304" tIns="109728" bIns="73152"/>
+          <a:lstStyle/>
+          <a:p>
+            <a:pPr algn="ctr">
+              <a:defRPr sz="900" b="1">
+                <a:solidFill>
+                  <a:srgbClr val="A0AEC0"/>
+                </a:solidFill>
+              </a:defRPr>
+            </a:pPr>
+            <a:r>
+              <a:t>Before probe</a:t>
+            </a:r>
+          </a:p>
+          <a:p>
+            <a:pPr>
+              <a:defRPr sz="2200" b="1">
+                <a:solidFill>
+                  <a:srgbClr val="F87171"/>
+                </a:solidFill>
+              </a:defRPr>
+            </a:pPr>
+            <a:r>
+              <a:t>14 findings</a:t>
+            </a:r>
+          </a:p>
+          <a:p>
+            <a:pPr>
+              <a:defRPr sz="900">
+                <a:solidFill>
+                  <a:srgbClr val="CBD5E1"/>
+                </a:solidFill>
+              </a:defRPr>
+            </a:pPr>
+            <a:r>
+              <a:t>2 Critical / 11 High / 1 Medium</a:t>
+            </a:r>
+          </a:p>
+        </p:txBody>
+      </p:sp>
+      <p:sp>
+        <p:nvSpPr>
+          <p:cNvPr id="6" name="Rounded Rectangle 5"/>
+          <p:cNvSpPr/>
+          <p:nvPr/>
+        </p:nvSpPr>
+        <p:spPr>
+          <a:xfrm>
+            <a:off x="3337560" y="1417320"/>
+            <a:ext cx="2514600" cy="1051560"/>
+          </a:xfrm>
+          <a:prstGeom prst="roundRect">
+            <a:avLst/>
+          </a:prstGeom>
+          <a:solidFill>
+            <a:srgbClr val="161E30"/>
+          </a:solidFill>
+          <a:ln w="12700">
+            <a:solidFill>
+              <a:srgbClr val="2F3A52"/>
+            </a:solidFill>
+          </a:ln>
+        </p:spPr>
+        <p:style>
+          <a:lnRef idx="1">
+            <a:schemeClr val="accent1"/>
+          </a:lnRef>
+          <a:fillRef idx="3">
+            <a:schemeClr val="accent1"/>
+          </a:fillRef>
+          <a:effectRef idx="2">
+            <a:schemeClr val="accent1"/>
+          </a:effectRef>
+          <a:fontRef idx="minor">
+            <a:schemeClr val="lt1"/>
+          </a:fontRef>
+        </p:style>
+        <p:txBody>
+          <a:bodyPr rtlCol="0" anchor="ctr" lIns="146304" rIns="146304" tIns="109728" bIns="73152"/>
+          <a:lstStyle/>
+          <a:p>
+            <a:pPr algn="ctr">
+              <a:defRPr sz="900" b="1">
+                <a:solidFill>
+                  <a:srgbClr val="A0AEC0"/>
+                </a:solidFill>
+              </a:defRPr>
+            </a:pPr>
+            <a:r>
+              <a:t>After probe</a:t>
+            </a:r>
+          </a:p>
+          <a:p>
+            <a:pPr>
+              <a:defRPr sz="2200" b="1">
+                <a:solidFill>
+                  <a:srgbClr val="FACC15"/>
+                </a:solidFill>
+              </a:defRPr>
+            </a:pPr>
+            <a:r>
+              <a:t>11 findings</a:t>
+            </a:r>
+          </a:p>
+          <a:p>
+            <a:pPr>
+              <a:defRPr sz="900">
+                <a:solidFill>
+                  <a:srgbClr val="CBD5E1"/>
+                </a:solidFill>
+              </a:defRPr>
+            </a:pPr>
+            <a:r>
+              <a:t>13 of 14 checks passing</a:t>
+            </a:r>
+          </a:p>
+        </p:txBody>
+      </p:sp>
+      <p:sp>
+        <p:nvSpPr>
+          <p:cNvPr id="7" name="Rounded Rectangle 6"/>
+          <p:cNvSpPr/>
+          <p:nvPr/>
+        </p:nvSpPr>
+        <p:spPr>
+          <a:xfrm>
+            <a:off x="6080760" y="1417320"/>
+            <a:ext cx="2514600" cy="1051560"/>
+          </a:xfrm>
+          <a:prstGeom prst="roundRect">
+            <a:avLst/>
+          </a:prstGeom>
+          <a:solidFill>
+            <a:srgbClr val="161E30"/>
+          </a:solidFill>
+          <a:ln w="12700">
+            <a:solidFill>
+              <a:srgbClr val="2F3A52"/>
+            </a:solidFill>
+          </a:ln>
+        </p:spPr>
+        <p:style>
+          <a:lnRef idx="1">
+            <a:schemeClr val="accent1"/>
+          </a:lnRef>
+          <a:fillRef idx="3">
+            <a:schemeClr val="accent1"/>
+          </a:fillRef>
+          <a:effectRef idx="2">
+            <a:schemeClr val="accent1"/>
+          </a:effectRef>
+          <a:fontRef idx="minor">
+            <a:schemeClr val="lt1"/>
+          </a:fontRef>
+        </p:style>
+        <p:txBody>
+          <a:bodyPr rtlCol="0" anchor="ctr" lIns="146304" rIns="146304" tIns="109728" bIns="73152"/>
+          <a:lstStyle/>
+          <a:p>
+            <a:pPr algn="ctr">
+              <a:defRPr sz="900" b="1">
+                <a:solidFill>
+                  <a:srgbClr val="A0AEC0"/>
+                </a:solidFill>
+              </a:defRPr>
+            </a:pPr>
+            <a:r>
+              <a:t>Fix target</a:t>
+            </a:r>
+          </a:p>
+          <a:p>
+            <a:pPr>
+              <a:defRPr sz="2200" b="1">
+                <a:solidFill>
+                  <a:srgbClr val="4ADE80"/>
+                </a:solidFill>
+              </a:defRPr>
+            </a:pPr>
+            <a:r>
+              <a:t>2 closed</a:t>
+            </a:r>
+          </a:p>
+          <a:p>
+            <a:pPr>
+              <a:defRPr sz="900">
+                <a:solidFill>
+                  <a:srgbClr val="CBD5E1"/>
+                </a:solidFill>
+              </a:defRPr>
+            </a:pPr>
+            <a:r>
+              <a:t>CSP + WebSocket validation</a:t>
+            </a:r>
+          </a:p>
+        </p:txBody>
+      </p:sp>
+      <p:sp>
+        <p:nvSpPr>
+          <p:cNvPr id="8" name="Rounded Rectangle 7"/>
+          <p:cNvSpPr/>
+          <p:nvPr/>
+        </p:nvSpPr>
+        <p:spPr>
+          <a:xfrm>
+            <a:off x="8823960" y="1417320"/>
+            <a:ext cx="2514600" cy="1051560"/>
+          </a:xfrm>
+          <a:prstGeom prst="roundRect">
+            <a:avLst/>
+          </a:prstGeom>
+          <a:solidFill>
+            <a:srgbClr val="161E30"/>
+          </a:solidFill>
+          <a:ln w="12700">
+            <a:solidFill>
+              <a:srgbClr val="2F3A52"/>
+            </a:solidFill>
+          </a:ln>
+        </p:spPr>
+        <p:style>
+          <a:lnRef idx="1">
+            <a:schemeClr val="accent1"/>
+          </a:lnRef>
+          <a:fillRef idx="3">
+            <a:schemeClr val="accent1"/>
+          </a:fillRef>
+          <a:effectRef idx="2">
+            <a:schemeClr val="accent1"/>
+          </a:effectRef>
+          <a:fontRef idx="minor">
+            <a:schemeClr val="lt1"/>
+          </a:fontRef>
+        </p:style>
+        <p:txBody>
+          <a:bodyPr rtlCol="0" anchor="ctr" lIns="146304" rIns="146304" tIns="109728" bIns="73152"/>
+          <a:lstStyle/>
+          <a:p>
+            <a:pPr algn="ctr">
+              <a:defRPr sz="900" b="1">
+                <a:solidFill>
+                  <a:srgbClr val="A0AEC0"/>
+                </a:solidFill>
+              </a:defRPr>
+            </a:pPr>
+            <a:r>
+              <a:t>Regression suites</a:t>
+            </a:r>
+          </a:p>
+          <a:p>
+            <a:pPr>
+              <a:defRPr sz="2200" b="1">
+                <a:solidFill>
+                  <a:srgbClr val="60A5FA"/>
+                </a:solidFill>
+              </a:defRPr>
+            </a:pPr>
+            <a:r>
+              <a:t>622 tests</a:t>
+            </a:r>
+          </a:p>
+          <a:p>
+            <a:pPr>
+              <a:defRPr sz="900">
+                <a:solidFill>
+                  <a:srgbClr val="CBD5E1"/>
+                </a:solidFill>
+              </a:defRPr>
+            </a:pPr>
+            <a:r>
+              <a:t>API 465 + Web 157 passed</a:t>
+            </a:r>
+          </a:p>
+        </p:txBody>
+      </p:sp>
+      <p:sp>
+        <p:nvSpPr>
+          <p:cNvPr id="9" name="TextBox 8"/>
+          <p:cNvSpPr txBox="1"/>
+          <p:nvPr/>
+        </p:nvSpPr>
+        <p:spPr>
+          <a:xfrm>
+            <a:off x="685800" y="2788920"/>
+            <a:ext cx="5257800" cy="2377440"/>
+          </a:xfrm>
+          <a:prstGeom prst="rect">
+            <a:avLst/>
+          </a:prstGeom>
+          <a:noFill/>
+        </p:spPr>
+        <p:txBody>
+          <a:bodyPr wrap="none">
+            <a:spAutoFit/>
+          </a:bodyPr>
+          <a:lstStyle/>
+          <a:p>
+            <a:pPr>
+              <a:defRPr sz="1600" b="1">
+                <a:solidFill>
+                  <a:srgbClr val="F8FAFC"/>
+                </a:solidFill>
+              </a:defRPr>
+            </a:pPr>
+            <a:r>
+              <a:t>Probe coverage</a:t>
+            </a:r>
+          </a:p>
+          <a:p>
+            <a:pPr>
+              <a:spcAft>
+                <a:spcPts val="500"/>
+              </a:spcAft>
+              <a:defRPr sz="1100">
+                <a:solidFill>
+                  <a:srgbClr val="DBE2EC"/>
+                </a:solidFill>
+              </a:defRPr>
+            </a:pPr>
+            <a:r>
+              <a:t>Auth/session checks: protected route rejection, login, session entropy, member privilege boundary</a:t>
+            </a:r>
+          </a:p>
+          <a:p>
+            <a:pPr>
+              <a:spcAft>
+                <a:spcPts val="500"/>
+              </a:spcAft>
+              <a:defRPr sz="1100">
+                <a:solidFill>
+                  <a:srgbClr val="DBE2EC"/>
+                </a:solidFill>
+              </a:defRPr>
+            </a:pPr>
+            <a:r>
+              <a:t>WebSocket checks: unauthenticated access, unsupported type, malformed frame, oversized payload</a:t>
+            </a:r>
+          </a:p>
+          <a:p>
+            <a:pPr>
+              <a:spcAft>
+                <a:spcPts val="500"/>
+              </a:spcAft>
+              <a:defRPr sz="1100">
+                <a:solidFill>
+                  <a:srgbClr val="DBE2EC"/>
+                </a:solidFill>
+              </a:defRPr>
+            </a:pPr>
+            <a:r>
+              <a:t>Input sanitization and production dependency audit with JSON/Markdown reports</a:t>
+            </a:r>
+          </a:p>
+          <a:p>
+            <a:pPr>
+              <a:spcAft>
+                <a:spcPts val="500"/>
+              </a:spcAft>
+              <a:defRPr sz="1100">
+                <a:solidFill>
+                  <a:srgbClr val="DBE2EC"/>
+                </a:solidFill>
+              </a:defRPr>
+            </a:pPr>
+            <a:r>
+              <a:t>Manual review: CORS/CSP, secrets, rate limits, verbose error leakage</a:t>
+            </a:r>
+          </a:p>
+        </p:txBody>
+      </p:sp>
+      <p:sp>
+        <p:nvSpPr>
+          <p:cNvPr id="10" name="TextBox 9"/>
+          <p:cNvSpPr txBox="1"/>
+          <p:nvPr/>
+        </p:nvSpPr>
+        <p:spPr>
+          <a:xfrm>
+            <a:off x="6309360" y="2788920"/>
+            <a:ext cx="5257800" cy="2377440"/>
+          </a:xfrm>
+          <a:prstGeom prst="rect">
+            <a:avLst/>
+          </a:prstGeom>
+          <a:noFill/>
+        </p:spPr>
+        <p:txBody>
+          <a:bodyPr wrap="none">
+            <a:spAutoFit/>
+          </a:bodyPr>
+          <a:lstStyle/>
+          <a:p>
+            <a:pPr>
+              <a:defRPr sz="1600" b="1">
+                <a:solidFill>
+                  <a:srgbClr val="F8FAFC"/>
+                </a:solidFill>
+              </a:defRPr>
+            </a:pPr>
+            <a:r>
+              <a:t>After-fix state</a:t>
+            </a:r>
+          </a:p>
+          <a:p>
+            <a:pPr>
+              <a:spcAft>
+                <a:spcPts val="500"/>
+              </a:spcAft>
+              <a:defRPr sz="1100">
+                <a:solidFill>
+                  <a:srgbClr val="DBE2EC"/>
+                </a:solidFill>
+              </a:defRPr>
+            </a:pPr>
+            <a:r>
+              <a:t>CSP script-src now uses a per-request nonce; unsafe-inline removed from scripts</a:t>
+            </a:r>
+          </a:p>
+          <a:p>
+            <a:pPr>
+              <a:spcAft>
+                <a:spcPts val="500"/>
+              </a:spcAft>
+              <a:defRPr sz="1100">
+                <a:solidFill>
+                  <a:srgbClr val="DBE2EC"/>
+                </a:solidFill>
+              </a:defRPr>
+            </a:pPr>
+            <a:r>
+              <a:t>Malformed collaboration messages close with 1003 and no longer crash the API</a:t>
+            </a:r>
+          </a:p>
+          <a:p>
+            <a:pPr>
+              <a:spcAft>
+                <a:spcPts val="500"/>
+              </a:spcAft>
+              <a:defRPr sz="1100">
+                <a:solidFill>
+                  <a:srgbClr val="DBE2EC"/>
+                </a:solidFill>
+              </a:defRPr>
+            </a:pPr>
+            <a:r>
+              <a:t>Oversized collaboration payloads close with 1009 and leave /health available</a:t>
+            </a:r>
+          </a:p>
+          <a:p>
+            <a:pPr>
+              <a:spcAft>
+                <a:spcPts val="500"/>
+              </a:spcAft>
+              <a:defRPr sz="1100">
+                <a:solidFill>
+                  <a:srgbClr val="DBE2EC"/>
+                </a:solidFill>
+              </a:defRPr>
+            </a:pPr>
+            <a:r>
+              <a:t>Remaining work: dependency upgrades and API title sanitization hardening</a:t>
+            </a:r>
+          </a:p>
+        </p:txBody>
+      </p:sp>
+      <p:sp>
+        <p:nvSpPr>
+          <p:cNvPr id="11" name="TextBox 10"/>
+          <p:cNvSpPr txBox="1"/>
+          <p:nvPr/>
+        </p:nvSpPr>
+        <p:spPr>
+          <a:xfrm>
+            <a:off x="685800" y="6263640"/>
+            <a:ext cx="10789920" cy="256032"/>
+          </a:xfrm>
+          <a:prstGeom prst="rect">
+            <a:avLst/>
+          </a:prstGeom>
+          <a:noFill/>
+        </p:spPr>
+        <p:txBody>
+          <a:bodyPr wrap="none">
+            <a:spAutoFit/>
+          </a:bodyPr>
+          <a:lstStyle/>
+          <a:p>
+            <a:pPr algn="ctr">
+              <a:defRPr sz="900">
+                <a:solidFill>
+                  <a:srgbClr val="94A3B8"/>
+                </a:solidFill>
+              </a:defRPr>
+            </a:pPr>
+            <a:r>
+              <a:t>Artifacts: scripts/security-probe.mjs, shipshape/SECURITY_PROBE.md, shipshape/shipshape-evidence/security-probe-before|after.{json,md}</a:t>
+            </a:r>
+          </a:p>
+        </p:txBody>
+      </p:sp>
     </p:spTree>
   </p:cSld>
   <p:clrMapOvr>

</xml_diff>

<commit_message>
Grade and harden ShipShape submission
</commit_message>
<xml_diff>
--- a/shipshape/ShipShape_Demo_Deck.pptx
+++ b/shipshape/ShipShape_Demo_Deck.pptx
@@ -4429,7 +4429,7 @@
               </a:defRPr>
             </a:pPr>
             <a:r>
-              <a:t>11 findings</a:t>
+              <a:t>12 findings</a:t>
             </a:r>
           </a:p>
           <a:p>
@@ -4441,7 +4441,7 @@
               </a:defRPr>
             </a:pPr>
             <a:r>
-              <a:t>13 of 14 checks passing</a:t>
+              <a:t>14 of 16 checks passing</a:t>
             </a:r>
           </a:p>
         </p:txBody>
@@ -4787,7 +4787,7 @@
               </a:defRPr>
             </a:pPr>
             <a:r>
-              <a:t>Remaining work: dependency upgrades and API title sanitization hardening</a:t>
+              <a:t>Remaining work: dependency upgrades and title/content sanitization hardening</a:t>
             </a:r>
           </a:p>
         </p:txBody>

</xml_diff>

<commit_message>
Extend final stretch goals
</commit_message>
<xml_diff>
--- a/shipshape/ShipShape_Demo_Deck.pptx
+++ b/shipshape/ShipShape_Demo_Deck.pptx
@@ -37,6 +37,7 @@
     <p:sldId id="285" r:id="rId40"/>
     <p:sldId id="286" r:id="rId41"/>
     <p:sldId id="287" r:id="rId42"/>
+    <p:sldId id="288" r:id="rId43"/>
   </p:sldIdLst>
   <p:sldSz cx="14630400" cy="8229600" type="screen4x3"/>
   <p:notesSz cx="6858000" cy="9144000"/>
@@ -4823,6 +4824,726 @@
             </a:pPr>
             <a:r>
               <a:t>Artifacts: scripts/security-probe.mjs, shipshape/SECURITY_PROBE.md, shipshape/shipshape-evidence/security-probe-before|after.{json,md}</a:t>
+            </a:r>
+          </a:p>
+        </p:txBody>
+      </p:sp>
+    </p:spTree>
+  </p:cSld>
+  <p:clrMapOvr>
+    <a:masterClrMapping/>
+  </p:clrMapOvr>
+</p:sld>
+</file>
+
+<file path=ppt/slides/slide33.xml><?xml version="1.0" encoding="utf-8"?>
+<p:sld xmlns:a="http://schemas.openxmlformats.org/drawingml/2006/main" xmlns:p="http://schemas.openxmlformats.org/presentationml/2006/main" xmlns:r="http://schemas.openxmlformats.org/officeDocument/2006/relationships">
+  <p:cSld>
+    <p:bg>
+      <p:bgPr>
+        <a:solidFill>
+          <a:srgbClr val="0F172A"/>
+        </a:solidFill>
+        <a:effectLst/>
+      </p:bgPr>
+    </p:bg>
+    <p:spTree>
+      <p:nvGrpSpPr>
+        <p:cNvPr id="1" name=""/>
+        <p:cNvGrpSpPr/>
+        <p:nvPr/>
+      </p:nvGrpSpPr>
+      <p:grpSpPr/>
+      <p:sp>
+        <p:nvSpPr>
+          <p:cNvPr id="2" name="TextBox 1"/>
+          <p:cNvSpPr txBox="1"/>
+          <p:nvPr/>
+        </p:nvSpPr>
+        <p:spPr>
+          <a:xfrm>
+            <a:off x="502920" y="320040"/>
+            <a:ext cx="11155680" cy="502920"/>
+          </a:xfrm>
+          <a:prstGeom prst="rect">
+            <a:avLst/>
+          </a:prstGeom>
+          <a:noFill/>
+        </p:spPr>
+        <p:txBody>
+          <a:bodyPr wrap="none">
+            <a:spAutoFit/>
+          </a:bodyPr>
+          <a:lstStyle/>
+          <a:p>
+            <a:pPr>
+              <a:defRPr sz="2600" b="1">
+                <a:solidFill>
+                  <a:srgbClr val="F8FAFC"/>
+                </a:solidFill>
+              </a:defRPr>
+            </a:pPr>
+            <a:r>
+              <a:t>MVP Stretch Goals -&gt; Final Stretch Goals</a:t>
+            </a:r>
+          </a:p>
+        </p:txBody>
+      </p:sp>
+      <p:sp>
+        <p:nvSpPr>
+          <p:cNvPr id="3" name="TextBox 2"/>
+          <p:cNvSpPr txBox="1"/>
+          <p:nvPr/>
+        </p:nvSpPr>
+        <p:spPr>
+          <a:xfrm>
+            <a:off x="548640" y="868680"/>
+            <a:ext cx="11064240" cy="320040"/>
+          </a:xfrm>
+          <a:prstGeom prst="rect">
+            <a:avLst/>
+          </a:prstGeom>
+          <a:noFill/>
+        </p:spPr>
+        <p:txBody>
+          <a:bodyPr wrap="none">
+            <a:spAutoFit/>
+          </a:bodyPr>
+          <a:lstStyle/>
+          <a:p>
+            <a:pPr>
+              <a:defRPr sz="1300">
+                <a:solidFill>
+                  <a:srgbClr val="CBD5E1"/>
+                </a:solidFill>
+              </a:defRPr>
+            </a:pPr>
+            <a:r>
+              <a:t>Final pass tightened the first seven audit categories without erasing the original MVP bar.</a:t>
+            </a:r>
+          </a:p>
+        </p:txBody>
+      </p:sp>
+      <p:sp>
+        <p:nvSpPr>
+          <p:cNvPr id="4" name="Rectangle 3"/>
+          <p:cNvSpPr/>
+          <p:nvPr/>
+        </p:nvSpPr>
+        <p:spPr>
+          <a:xfrm>
+            <a:off x="548640" y="1417320"/>
+            <a:ext cx="3246120" cy="4983480"/>
+          </a:xfrm>
+          <a:prstGeom prst="rect">
+            <a:avLst/>
+          </a:prstGeom>
+          <a:solidFill>
+            <a:srgbClr val="1E293B"/>
+          </a:solidFill>
+          <a:ln>
+            <a:solidFill>
+              <a:srgbClr val="475569"/>
+            </a:solidFill>
+          </a:ln>
+        </p:spPr>
+        <p:style>
+          <a:lnRef idx="1">
+            <a:schemeClr val="accent1"/>
+          </a:lnRef>
+          <a:fillRef idx="3">
+            <a:schemeClr val="accent1"/>
+          </a:fillRef>
+          <a:effectRef idx="2">
+            <a:schemeClr val="accent1"/>
+          </a:effectRef>
+          <a:fontRef idx="minor">
+            <a:schemeClr val="lt1"/>
+          </a:fontRef>
+        </p:style>
+        <p:txBody>
+          <a:bodyPr rtlCol="0" anchor="ctr"/>
+          <a:lstStyle/>
+          <a:p>
+            <a:pPr algn="ctr"/>
+          </a:p>
+        </p:txBody>
+      </p:sp>
+      <p:sp>
+        <p:nvSpPr>
+          <p:cNvPr id="5" name="TextBox 4"/>
+          <p:cNvSpPr txBox="1"/>
+          <p:nvPr/>
+        </p:nvSpPr>
+        <p:spPr>
+          <a:xfrm>
+            <a:off x="749808" y="1600200"/>
+            <a:ext cx="2852928" cy="320040"/>
+          </a:xfrm>
+          <a:prstGeom prst="rect">
+            <a:avLst/>
+          </a:prstGeom>
+          <a:noFill/>
+        </p:spPr>
+        <p:txBody>
+          <a:bodyPr wrap="none">
+            <a:spAutoFit/>
+          </a:bodyPr>
+          <a:lstStyle/>
+          <a:p>
+            <a:pPr>
+              <a:defRPr sz="1500" b="1">
+                <a:solidFill>
+                  <a:srgbClr val="F8FAFC"/>
+                </a:solidFill>
+              </a:defRPr>
+            </a:pPr>
+            <a:r>
+              <a:t>MVP stretch goal</a:t>
+            </a:r>
+          </a:p>
+        </p:txBody>
+      </p:sp>
+      <p:sp>
+        <p:nvSpPr>
+          <p:cNvPr id="6" name="TextBox 5"/>
+          <p:cNvSpPr txBox="1"/>
+          <p:nvPr/>
+        </p:nvSpPr>
+        <p:spPr>
+          <a:xfrm>
+            <a:off x="749808" y="2057400"/>
+            <a:ext cx="2852928" cy="4160520"/>
+          </a:xfrm>
+          <a:prstGeom prst="rect">
+            <a:avLst/>
+          </a:prstGeom>
+          <a:noFill/>
+        </p:spPr>
+        <p:txBody>
+          <a:bodyPr wrap="square">
+            <a:spAutoFit/>
+          </a:bodyPr>
+          <a:lstStyle/>
+          <a:p>
+            <a:pPr>
+              <a:spcAft>
+                <a:spcPts val="700"/>
+              </a:spcAft>
+              <a:defRPr sz="1050">
+                <a:solidFill>
+                  <a:srgbClr val="E2E8F0"/>
+                </a:solidFill>
+              </a:defRPr>
+            </a:pPr>
+            <a:r>
+              <a:t>20% initial bundle reduction</a:t>
+            </a:r>
+          </a:p>
+          <a:p>
+            <a:pPr>
+              <a:spcAft>
+                <a:spcPts val="700"/>
+              </a:spcAft>
+              <a:defRPr sz="1050">
+                <a:solidFill>
+                  <a:srgbClr val="E2E8F0"/>
+                </a:solidFill>
+              </a:defRPr>
+            </a:pPr>
+            <a:r>
+              <a:t>API + web Vitest green</a:t>
+            </a:r>
+          </a:p>
+          <a:p>
+            <a:pPr>
+              <a:spcAft>
+                <a:spcPts val="700"/>
+              </a:spcAft>
+              <a:defRPr sz="1050">
+                <a:solidFill>
+                  <a:srgbClr val="E2E8F0"/>
+                </a:solidFill>
+              </a:defRPr>
+            </a:pPr>
+            <a:r>
+              <a:t>API/web V8 coverage reports</a:t>
+            </a:r>
+          </a:p>
+          <a:p>
+            <a:pPr>
+              <a:spcAft>
+                <a:spcPts val="700"/>
+              </a:spcAft>
+              <a:defRPr sz="1050">
+                <a:solidFill>
+                  <a:srgbClr val="E2E8F0"/>
+                </a:solidFill>
+              </a:defRPr>
+            </a:pPr>
+            <a:r>
+              <a:t>80% changed-line coverage</a:t>
+            </a:r>
+          </a:p>
+          <a:p>
+            <a:pPr>
+              <a:spcAft>
+                <a:spcPts val="700"/>
+              </a:spcAft>
+              <a:defRPr sz="1050">
+                <a:solidFill>
+                  <a:srgbClr val="E2E8F0"/>
+                </a:solidFill>
+              </a:defRPr>
+            </a:pPr>
+            <a:r>
+              <a:t>20% P95 reduction on two endpoints</a:t>
+            </a:r>
+          </a:p>
+          <a:p>
+            <a:pPr>
+              <a:spcAft>
+                <a:spcPts val="700"/>
+              </a:spcAft>
+              <a:defRPr sz="1050">
+                <a:solidFill>
+                  <a:srgbClr val="E2E8F0"/>
+                </a:solidFill>
+              </a:defRPr>
+            </a:pPr>
+            <a:r>
+              <a:t>20% main-flow query-count reduction</a:t>
+            </a:r>
+          </a:p>
+          <a:p>
+            <a:pPr>
+              <a:spcAft>
+                <a:spcPts val="700"/>
+              </a:spcAft>
+              <a:defRPr sz="1050">
+                <a:solidFill>
+                  <a:srgbClr val="E2E8F0"/>
+                </a:solidFill>
+              </a:defRPr>
+            </a:pPr>
+            <a:r>
+              <a:t>0 Critical/Serious axe issues on target pages</a:t>
+            </a:r>
+          </a:p>
+        </p:txBody>
+      </p:sp>
+      <p:sp>
+        <p:nvSpPr>
+          <p:cNvPr id="7" name="Rectangle 6"/>
+          <p:cNvSpPr/>
+          <p:nvPr/>
+        </p:nvSpPr>
+        <p:spPr>
+          <a:xfrm>
+            <a:off x="4160520" y="1417320"/>
+            <a:ext cx="3246120" cy="4983480"/>
+          </a:xfrm>
+          <a:prstGeom prst="rect">
+            <a:avLst/>
+          </a:prstGeom>
+          <a:solidFill>
+            <a:srgbClr val="164E63"/>
+          </a:solidFill>
+          <a:ln>
+            <a:solidFill>
+              <a:srgbClr val="475569"/>
+            </a:solidFill>
+          </a:ln>
+        </p:spPr>
+        <p:style>
+          <a:lnRef idx="1">
+            <a:schemeClr val="accent1"/>
+          </a:lnRef>
+          <a:fillRef idx="3">
+            <a:schemeClr val="accent1"/>
+          </a:fillRef>
+          <a:effectRef idx="2">
+            <a:schemeClr val="accent1"/>
+          </a:effectRef>
+          <a:fontRef idx="minor">
+            <a:schemeClr val="lt1"/>
+          </a:fontRef>
+        </p:style>
+        <p:txBody>
+          <a:bodyPr rtlCol="0" anchor="ctr"/>
+          <a:lstStyle/>
+          <a:p>
+            <a:pPr algn="ctr"/>
+          </a:p>
+        </p:txBody>
+      </p:sp>
+      <p:sp>
+        <p:nvSpPr>
+          <p:cNvPr id="8" name="TextBox 7"/>
+          <p:cNvSpPr txBox="1"/>
+          <p:nvPr/>
+        </p:nvSpPr>
+        <p:spPr>
+          <a:xfrm>
+            <a:off x="4361688" y="1600200"/>
+            <a:ext cx="2852928" cy="320040"/>
+          </a:xfrm>
+          <a:prstGeom prst="rect">
+            <a:avLst/>
+          </a:prstGeom>
+          <a:noFill/>
+        </p:spPr>
+        <p:txBody>
+          <a:bodyPr wrap="none">
+            <a:spAutoFit/>
+          </a:bodyPr>
+          <a:lstStyle/>
+          <a:p>
+            <a:pPr>
+              <a:defRPr sz="1500" b="1">
+                <a:solidFill>
+                  <a:srgbClr val="F8FAFC"/>
+                </a:solidFill>
+              </a:defRPr>
+            </a:pPr>
+            <a:r>
+              <a:t>Final stretch goal</a:t>
+            </a:r>
+          </a:p>
+        </p:txBody>
+      </p:sp>
+      <p:sp>
+        <p:nvSpPr>
+          <p:cNvPr id="9" name="TextBox 8"/>
+          <p:cNvSpPr txBox="1"/>
+          <p:nvPr/>
+        </p:nvSpPr>
+        <p:spPr>
+          <a:xfrm>
+            <a:off x="4361688" y="2057400"/>
+            <a:ext cx="2852928" cy="4160520"/>
+          </a:xfrm>
+          <a:prstGeom prst="rect">
+            <a:avLst/>
+          </a:prstGeom>
+          <a:noFill/>
+        </p:spPr>
+        <p:txBody>
+          <a:bodyPr wrap="square">
+            <a:spAutoFit/>
+          </a:bodyPr>
+          <a:lstStyle/>
+          <a:p>
+            <a:pPr>
+              <a:spcAft>
+                <a:spcPts val="700"/>
+              </a:spcAft>
+              <a:defRPr sz="1050">
+                <a:solidFill>
+                  <a:srgbClr val="E2E8F0"/>
+                </a:solidFill>
+              </a:defRPr>
+            </a:pPr>
+            <a:r>
+              <a:t>Large PropertyRow async chunk warning closed</a:t>
+            </a:r>
+          </a:p>
+          <a:p>
+            <a:pPr>
+              <a:spcAft>
+                <a:spcPts val="700"/>
+              </a:spcAft>
+              <a:defRPr sz="1050">
+                <a:solidFill>
+                  <a:srgbClr val="E2E8F0"/>
+                </a:solidFill>
+              </a:defRPr>
+            </a:pPr>
+            <a:r>
+              <a:t>Root pnpm test runs API and web</a:t>
+            </a:r>
+          </a:p>
+          <a:p>
+            <a:pPr>
+              <a:spcAft>
+                <a:spcPts val="700"/>
+              </a:spcAft>
+              <a:defRPr sz="1050">
+                <a:solidFill>
+                  <a:srgbClr val="E2E8F0"/>
+                </a:solidFill>
+              </a:defRPr>
+            </a:pPr>
+            <a:r>
+              <a:t>Coverage ratchets still pass after final changes</a:t>
+            </a:r>
+          </a:p>
+          <a:p>
+            <a:pPr>
+              <a:spcAft>
+                <a:spcPts val="700"/>
+              </a:spcAft>
+              <a:defRPr sz="1050">
+                <a:solidFill>
+                  <a:srgbClr val="E2E8F0"/>
+                </a:solidFill>
+              </a:defRPr>
+            </a:pPr>
+            <a:r>
+              <a:t>423/423 changed executable unit lines covered</a:t>
+            </a:r>
+          </a:p>
+          <a:p>
+            <a:pPr>
+              <a:spcAft>
+                <a:spcPts val="700"/>
+              </a:spcAft>
+              <a:defRPr sz="1050">
+                <a:solidFill>
+                  <a:srgbClr val="E2E8F0"/>
+                </a:solidFill>
+              </a:defRPr>
+            </a:pPr>
+            <a:r>
+              <a:t>Security-probe and axe exclusions named explicitly</a:t>
+            </a:r>
+          </a:p>
+          <a:p>
+            <a:pPr>
+              <a:spcAft>
+                <a:spcPts val="700"/>
+              </a:spcAft>
+              <a:defRPr sz="1050">
+                <a:solidFill>
+                  <a:srgbClr val="E2E8F0"/>
+                </a:solidFill>
+              </a:defRPr>
+            </a:pPr>
+            <a:r>
+              <a:t>Build has no Vite chunk-size or mixed import warnings</a:t>
+            </a:r>
+          </a:p>
+          <a:p>
+            <a:pPr>
+              <a:spcAft>
+                <a:spcPts val="700"/>
+              </a:spcAft>
+              <a:defRPr sz="1050">
+                <a:solidFill>
+                  <a:srgbClr val="E2E8F0"/>
+                </a:solidFill>
+              </a:defRPr>
+            </a:pPr>
+            <a:r>
+              <a:t>Grader feedback artifacts are committed and cross-linked</a:t>
+            </a:r>
+          </a:p>
+        </p:txBody>
+      </p:sp>
+      <p:sp>
+        <p:nvSpPr>
+          <p:cNvPr id="10" name="Rectangle 9"/>
+          <p:cNvSpPr/>
+          <p:nvPr/>
+        </p:nvSpPr>
+        <p:spPr>
+          <a:xfrm>
+            <a:off x="7772400" y="1417320"/>
+            <a:ext cx="3246120" cy="4983480"/>
+          </a:xfrm>
+          <a:prstGeom prst="rect">
+            <a:avLst/>
+          </a:prstGeom>
+          <a:solidFill>
+            <a:srgbClr val="374151"/>
+          </a:solidFill>
+          <a:ln>
+            <a:solidFill>
+              <a:srgbClr val="475569"/>
+            </a:solidFill>
+          </a:ln>
+        </p:spPr>
+        <p:style>
+          <a:lnRef idx="1">
+            <a:schemeClr val="accent1"/>
+          </a:lnRef>
+          <a:fillRef idx="3">
+            <a:schemeClr val="accent1"/>
+          </a:fillRef>
+          <a:effectRef idx="2">
+            <a:schemeClr val="accent1"/>
+          </a:effectRef>
+          <a:fontRef idx="minor">
+            <a:schemeClr val="lt1"/>
+          </a:fontRef>
+        </p:style>
+        <p:txBody>
+          <a:bodyPr rtlCol="0" anchor="ctr"/>
+          <a:lstStyle/>
+          <a:p>
+            <a:pPr algn="ctr"/>
+          </a:p>
+        </p:txBody>
+      </p:sp>
+      <p:sp>
+        <p:nvSpPr>
+          <p:cNvPr id="11" name="TextBox 10"/>
+          <p:cNvSpPr txBox="1"/>
+          <p:nvPr/>
+        </p:nvSpPr>
+        <p:spPr>
+          <a:xfrm>
+            <a:off x="7973568" y="1600200"/>
+            <a:ext cx="2852928" cy="320040"/>
+          </a:xfrm>
+          <a:prstGeom prst="rect">
+            <a:avLst/>
+          </a:prstGeom>
+          <a:noFill/>
+        </p:spPr>
+        <p:txBody>
+          <a:bodyPr wrap="none">
+            <a:spAutoFit/>
+          </a:bodyPr>
+          <a:lstStyle/>
+          <a:p>
+            <a:pPr>
+              <a:defRPr sz="1500" b="1">
+                <a:solidFill>
+                  <a:srgbClr val="F8FAFC"/>
+                </a:solidFill>
+              </a:defRPr>
+            </a:pPr>
+            <a:r>
+              <a:t>Current evidence</a:t>
+            </a:r>
+          </a:p>
+        </p:txBody>
+      </p:sp>
+      <p:sp>
+        <p:nvSpPr>
+          <p:cNvPr id="12" name="TextBox 11"/>
+          <p:cNvSpPr txBox="1"/>
+          <p:nvPr/>
+        </p:nvSpPr>
+        <p:spPr>
+          <a:xfrm>
+            <a:off x="7973568" y="2057400"/>
+            <a:ext cx="2852928" cy="4160520"/>
+          </a:xfrm>
+          <a:prstGeom prst="rect">
+            <a:avLst/>
+          </a:prstGeom>
+          <a:noFill/>
+        </p:spPr>
+        <p:txBody>
+          <a:bodyPr wrap="square">
+            <a:spAutoFit/>
+          </a:bodyPr>
+          <a:lstStyle/>
+          <a:p>
+            <a:pPr>
+              <a:spcAft>
+                <a:spcPts val="700"/>
+              </a:spcAft>
+              <a:defRPr sz="1050">
+                <a:solidFill>
+                  <a:srgbClr val="E2E8F0"/>
+                </a:solidFill>
+              </a:defRPr>
+            </a:pPr>
+            <a:r>
+              <a:t>Main app: 328.43 kB / 94.85 kB gzip</a:t>
+            </a:r>
+          </a:p>
+          <a:p>
+            <a:pPr>
+              <a:spcAft>
+                <a:spcPts val="700"/>
+              </a:spcAft>
+              <a:defRPr sz="1050">
+                <a:solidFill>
+                  <a:srgbClr val="E2E8F0"/>
+                </a:solidFill>
+              </a:defRPr>
+            </a:pPr>
+            <a:r>
+              <a:t>PropertyRow: 85.72 kB / 24.70 kB gzip</a:t>
+            </a:r>
+          </a:p>
+          <a:p>
+            <a:pPr>
+              <a:spcAft>
+                <a:spcPts val="700"/>
+              </a:spcAft>
+              <a:defRPr sz="1050">
+                <a:solidFill>
+                  <a:srgbClr val="E2E8F0"/>
+                </a:solidFill>
+              </a:defRPr>
+            </a:pPr>
+            <a:r>
+              <a:t>API: 29 files / 465 tests passed</a:t>
+            </a:r>
+          </a:p>
+          <a:p>
+            <a:pPr>
+              <a:spcAft>
+                <a:spcPts val="700"/>
+              </a:spcAft>
+              <a:defRPr sz="1050">
+                <a:solidFill>
+                  <a:srgbClr val="E2E8F0"/>
+                </a:solidFill>
+              </a:defRPr>
+            </a:pPr>
+            <a:r>
+              <a:t>Web: 19 files / 157 tests passed</a:t>
+            </a:r>
+          </a:p>
+          <a:p>
+            <a:pPr>
+              <a:spcAft>
+                <a:spcPts val="700"/>
+              </a:spcAft>
+              <a:defRPr sz="1050">
+                <a:solidFill>
+                  <a:srgbClr val="E2E8F0"/>
+                </a:solidFill>
+              </a:defRPr>
+            </a:pPr>
+            <a:r>
+              <a:t>API coverage: 41.25% line / 34.27% branch</a:t>
+            </a:r>
+          </a:p>
+          <a:p>
+            <a:pPr>
+              <a:spcAft>
+                <a:spcPts val="700"/>
+              </a:spcAft>
+              <a:defRPr sz="1050">
+                <a:solidFill>
+                  <a:srgbClr val="E2E8F0"/>
+                </a:solidFill>
+              </a:defRPr>
+            </a:pPr>
+            <a:r>
+              <a:t>Web coverage: 28.10% line / 16.60% branch</a:t>
+            </a:r>
+          </a:p>
+          <a:p>
+            <a:pPr>
+              <a:spcAft>
+                <a:spcPts val="700"/>
+              </a:spcAft>
+              <a:defRPr sz="1050">
+                <a:solidFill>
+                  <a:srgbClr val="E2E8F0"/>
+                </a:solidFill>
+              </a:defRPr>
+            </a:pPr>
+            <a:r>
+              <a:t>DISCOVERIES.md has exactly 3 entries</a:t>
             </a:r>
           </a:p>
         </p:txBody>

</xml_diff>